<commit_message>
dataset XML style edit
</commit_message>
<xml_diff>
--- a/documents/Vision Prediction.pptx
+++ b/documents/Vision Prediction.pptx
@@ -6546,167 +6546,6 @@
           <a:chExt cx="0" cy="0"/>
         </a:xfrm>
       </p:grpSpPr>
-      <p:grpSp>
-        <p:nvGrpSpPr>
-          <p:cNvPr id="15" name="그룹 14">
-            <a:extLst>
-              <a:ext uri="{FF2B5EF4-FFF2-40B4-BE49-F238E27FC236}">
-                <a16:creationId xmlns:a16="http://schemas.microsoft.com/office/drawing/2014/main" id="{6C7BAE3F-5A40-B6A0-CE7E-3524B40F6F53}"/>
-              </a:ext>
-            </a:extLst>
-          </p:cNvPr>
-          <p:cNvGrpSpPr/>
-          <p:nvPr/>
-        </p:nvGrpSpPr>
-        <p:grpSpPr>
-          <a:xfrm>
-            <a:off x="684361" y="735521"/>
-            <a:ext cx="1246040" cy="769429"/>
-            <a:chOff x="2919560" y="2710371"/>
-            <a:chExt cx="1595063" cy="953579"/>
-          </a:xfrm>
-        </p:grpSpPr>
-        <p:pic>
-          <p:nvPicPr>
-            <p:cNvPr id="5" name="그림 4">
-              <a:extLst>
-                <a:ext uri="{FF2B5EF4-FFF2-40B4-BE49-F238E27FC236}">
-                  <a16:creationId xmlns:a16="http://schemas.microsoft.com/office/drawing/2014/main" id="{C8B74491-5E85-23C6-5BF6-E9A6E557742B}"/>
-                </a:ext>
-              </a:extLst>
-            </p:cNvPr>
-            <p:cNvPicPr>
-              <a:picLocks noChangeAspect="1"/>
-            </p:cNvPicPr>
-            <p:nvPr/>
-          </p:nvPicPr>
-          <p:blipFill>
-            <a:blip r:embed="rId2"/>
-            <a:stretch>
-              <a:fillRect/>
-            </a:stretch>
-          </p:blipFill>
-          <p:spPr>
-            <a:xfrm>
-              <a:off x="2919560" y="2710371"/>
-              <a:ext cx="1480763" cy="832929"/>
-            </a:xfrm>
-            <a:prstGeom prst="rect">
-              <a:avLst/>
-            </a:prstGeom>
-            <a:ln>
-              <a:solidFill>
-                <a:schemeClr val="tx1"/>
-              </a:solidFill>
-            </a:ln>
-          </p:spPr>
-        </p:pic>
-        <p:pic>
-          <p:nvPicPr>
-            <p:cNvPr id="6" name="그림 5">
-              <a:extLst>
-                <a:ext uri="{FF2B5EF4-FFF2-40B4-BE49-F238E27FC236}">
-                  <a16:creationId xmlns:a16="http://schemas.microsoft.com/office/drawing/2014/main" id="{F8DBCCB7-036E-921D-EB95-0DF3975132A4}"/>
-                </a:ext>
-              </a:extLst>
-            </p:cNvPr>
-            <p:cNvPicPr>
-              <a:picLocks noChangeAspect="1"/>
-            </p:cNvPicPr>
-            <p:nvPr/>
-          </p:nvPicPr>
-          <p:blipFill>
-            <a:blip r:embed="rId2"/>
-            <a:stretch>
-              <a:fillRect/>
-            </a:stretch>
-          </p:blipFill>
-          <p:spPr>
-            <a:xfrm>
-              <a:off x="2951310" y="2742121"/>
-              <a:ext cx="1480763" cy="832929"/>
-            </a:xfrm>
-            <a:prstGeom prst="rect">
-              <a:avLst/>
-            </a:prstGeom>
-            <a:ln>
-              <a:solidFill>
-                <a:schemeClr val="tx1"/>
-              </a:solidFill>
-            </a:ln>
-          </p:spPr>
-        </p:pic>
-        <p:pic>
-          <p:nvPicPr>
-            <p:cNvPr id="7" name="그림 6">
-              <a:extLst>
-                <a:ext uri="{FF2B5EF4-FFF2-40B4-BE49-F238E27FC236}">
-                  <a16:creationId xmlns:a16="http://schemas.microsoft.com/office/drawing/2014/main" id="{4359A7F3-2B0B-D445-81C6-149CDCD75235}"/>
-                </a:ext>
-              </a:extLst>
-            </p:cNvPr>
-            <p:cNvPicPr>
-              <a:picLocks noChangeAspect="1"/>
-            </p:cNvPicPr>
-            <p:nvPr/>
-          </p:nvPicPr>
-          <p:blipFill>
-            <a:blip r:embed="rId2"/>
-            <a:stretch>
-              <a:fillRect/>
-            </a:stretch>
-          </p:blipFill>
-          <p:spPr>
-            <a:xfrm>
-              <a:off x="2989410" y="2786571"/>
-              <a:ext cx="1480763" cy="832929"/>
-            </a:xfrm>
-            <a:prstGeom prst="rect">
-              <a:avLst/>
-            </a:prstGeom>
-            <a:ln>
-              <a:solidFill>
-                <a:schemeClr val="tx1"/>
-              </a:solidFill>
-            </a:ln>
-          </p:spPr>
-        </p:pic>
-        <p:pic>
-          <p:nvPicPr>
-            <p:cNvPr id="8" name="그림 7">
-              <a:extLst>
-                <a:ext uri="{FF2B5EF4-FFF2-40B4-BE49-F238E27FC236}">
-                  <a16:creationId xmlns:a16="http://schemas.microsoft.com/office/drawing/2014/main" id="{97D45795-BE01-65FC-D3C8-5028447DA7E4}"/>
-                </a:ext>
-              </a:extLst>
-            </p:cNvPr>
-            <p:cNvPicPr>
-              <a:picLocks noChangeAspect="1"/>
-            </p:cNvPicPr>
-            <p:nvPr/>
-          </p:nvPicPr>
-          <p:blipFill>
-            <a:blip r:embed="rId2"/>
-            <a:stretch>
-              <a:fillRect/>
-            </a:stretch>
-          </p:blipFill>
-          <p:spPr>
-            <a:xfrm>
-              <a:off x="3033860" y="2831021"/>
-              <a:ext cx="1480763" cy="832929"/>
-            </a:xfrm>
-            <a:prstGeom prst="rect">
-              <a:avLst/>
-            </a:prstGeom>
-            <a:ln>
-              <a:solidFill>
-                <a:schemeClr val="tx1"/>
-              </a:solidFill>
-            </a:ln>
-          </p:spPr>
-        </p:pic>
-      </p:grpSp>
       <p:sp>
         <p:nvSpPr>
           <p:cNvPr id="19" name="TextBox 18">
@@ -7102,393 +6941,12 @@
           </a:p>
         </p:txBody>
       </p:sp>
-      <p:cxnSp>
-        <p:nvCxnSpPr>
-          <p:cNvPr id="21" name="직선 화살표 연결선 20">
-            <a:extLst>
-              <a:ext uri="{FF2B5EF4-FFF2-40B4-BE49-F238E27FC236}">
-                <a16:creationId xmlns:a16="http://schemas.microsoft.com/office/drawing/2014/main" id="{045EFB69-B97D-7AA0-D2AF-DDE4A65C9E73}"/>
-              </a:ext>
-            </a:extLst>
-          </p:cNvPr>
-          <p:cNvCxnSpPr>
-            <a:cxnSpLocks/>
-            <a:stCxn id="8" idx="3"/>
-            <a:endCxn id="25" idx="1"/>
-          </p:cNvCxnSpPr>
-          <p:nvPr/>
-        </p:nvCxnSpPr>
-        <p:spPr>
-          <a:xfrm flipV="1">
-            <a:off x="1930401" y="1166813"/>
-            <a:ext cx="393699" cy="2098"/>
-          </a:xfrm>
-          <a:prstGeom prst="straightConnector1">
-            <a:avLst/>
-          </a:prstGeom>
-          <a:ln>
-            <a:tailEnd type="triangle"/>
-          </a:ln>
-        </p:spPr>
-        <p:style>
-          <a:lnRef idx="2">
-            <a:schemeClr val="dk1"/>
-          </a:lnRef>
-          <a:fillRef idx="0">
-            <a:schemeClr val="dk1"/>
-          </a:fillRef>
-          <a:effectRef idx="1">
-            <a:schemeClr val="dk1"/>
-          </a:effectRef>
-          <a:fontRef idx="minor">
-            <a:schemeClr val="tx1"/>
-          </a:fontRef>
-        </p:style>
-      </p:cxnSp>
-      <p:sp>
-        <p:nvSpPr>
-          <p:cNvPr id="25" name="사각형: 둥근 모서리 24">
-            <a:extLst>
-              <a:ext uri="{FF2B5EF4-FFF2-40B4-BE49-F238E27FC236}">
-                <a16:creationId xmlns:a16="http://schemas.microsoft.com/office/drawing/2014/main" id="{1E29B1E4-15D5-6A4C-47C7-888103F5736F}"/>
-              </a:ext>
-            </a:extLst>
-          </p:cNvPr>
-          <p:cNvSpPr/>
-          <p:nvPr/>
-        </p:nvSpPr>
-        <p:spPr>
-          <a:xfrm>
-            <a:off x="2324100" y="933450"/>
-            <a:ext cx="1476375" cy="466725"/>
-          </a:xfrm>
-          <a:prstGeom prst="roundRect">
-            <a:avLst/>
-          </a:prstGeom>
-          <a:solidFill>
-            <a:schemeClr val="accent1">
-              <a:lumMod val="20000"/>
-              <a:lumOff val="80000"/>
-            </a:schemeClr>
-          </a:solidFill>
-          <a:ln>
-            <a:solidFill>
-              <a:schemeClr val="tx2">
-                <a:lumMod val="25000"/>
-                <a:lumOff val="75000"/>
-              </a:schemeClr>
-            </a:solidFill>
-          </a:ln>
-        </p:spPr>
-        <p:style>
-          <a:lnRef idx="2">
-            <a:schemeClr val="accent1">
-              <a:shade val="15000"/>
-            </a:schemeClr>
-          </a:lnRef>
-          <a:fillRef idx="1">
-            <a:schemeClr val="accent1"/>
-          </a:fillRef>
-          <a:effectRef idx="0">
-            <a:schemeClr val="accent1"/>
-          </a:effectRef>
-          <a:fontRef idx="minor">
-            <a:schemeClr val="lt1"/>
-          </a:fontRef>
-        </p:style>
-        <p:txBody>
-          <a:bodyPr rtlCol="0" anchor="ctr"/>
-          <a:lstStyle/>
-          <a:p>
-            <a:pPr algn="ctr"/>
-            <a:r>
-              <a:rPr lang="en-US" altLang="ko-KR" sz="1050" b="1" dirty="0">
-                <a:solidFill>
-                  <a:schemeClr val="tx1"/>
-                </a:solidFill>
-              </a:rPr>
-              <a:t>Spatial Backbone</a:t>
-            </a:r>
-          </a:p>
-          <a:p>
-            <a:pPr algn="ctr"/>
-            <a:r>
-              <a:rPr lang="en-US" altLang="ko-KR" sz="1050" b="1" dirty="0">
-                <a:solidFill>
-                  <a:schemeClr val="tx1"/>
-                </a:solidFill>
-              </a:rPr>
-              <a:t>(</a:t>
-            </a:r>
-            <a:r>
-              <a:rPr lang="en-US" altLang="ko-KR" sz="1050" b="1" dirty="0" err="1">
-                <a:solidFill>
-                  <a:schemeClr val="tx1"/>
-                </a:solidFill>
-              </a:rPr>
-              <a:t>ConvNeXt</a:t>
-            </a:r>
-            <a:r>
-              <a:rPr lang="en-US" altLang="ko-KR" sz="1050" b="1" dirty="0">
-                <a:solidFill>
-                  <a:schemeClr val="tx1"/>
-                </a:solidFill>
-              </a:rPr>
-              <a:t> V2)</a:t>
-            </a:r>
-            <a:endParaRPr lang="ko-KR" altLang="en-US" sz="1050" b="1" dirty="0">
-              <a:solidFill>
-                <a:schemeClr val="tx1"/>
-              </a:solidFill>
-            </a:endParaRPr>
-          </a:p>
-        </p:txBody>
-      </p:sp>
-      <p:cxnSp>
-        <p:nvCxnSpPr>
-          <p:cNvPr id="27" name="직선 화살표 연결선 26">
-            <a:extLst>
-              <a:ext uri="{FF2B5EF4-FFF2-40B4-BE49-F238E27FC236}">
-                <a16:creationId xmlns:a16="http://schemas.microsoft.com/office/drawing/2014/main" id="{19F8D02C-A6D4-F4DF-21D3-9465FC567C12}"/>
-              </a:ext>
-            </a:extLst>
-          </p:cNvPr>
-          <p:cNvCxnSpPr>
-            <a:cxnSpLocks/>
-            <a:endCxn id="28" idx="1"/>
-          </p:cNvCxnSpPr>
-          <p:nvPr/>
-        </p:nvCxnSpPr>
-        <p:spPr>
-          <a:xfrm flipV="1">
-            <a:off x="3806826" y="1166813"/>
-            <a:ext cx="393699" cy="2098"/>
-          </a:xfrm>
-          <a:prstGeom prst="straightConnector1">
-            <a:avLst/>
-          </a:prstGeom>
-          <a:ln>
-            <a:tailEnd type="triangle"/>
-          </a:ln>
-        </p:spPr>
-        <p:style>
-          <a:lnRef idx="2">
-            <a:schemeClr val="dk1"/>
-          </a:lnRef>
-          <a:fillRef idx="0">
-            <a:schemeClr val="dk1"/>
-          </a:fillRef>
-          <a:effectRef idx="1">
-            <a:schemeClr val="dk1"/>
-          </a:effectRef>
-          <a:fontRef idx="minor">
-            <a:schemeClr val="tx1"/>
-          </a:fontRef>
-        </p:style>
-      </p:cxnSp>
-      <p:sp>
-        <p:nvSpPr>
-          <p:cNvPr id="28" name="사각형: 둥근 모서리 27">
-            <a:extLst>
-              <a:ext uri="{FF2B5EF4-FFF2-40B4-BE49-F238E27FC236}">
-                <a16:creationId xmlns:a16="http://schemas.microsoft.com/office/drawing/2014/main" id="{6E556030-9809-4B16-4789-B5037AEAEF14}"/>
-              </a:ext>
-            </a:extLst>
-          </p:cNvPr>
-          <p:cNvSpPr/>
-          <p:nvPr/>
-        </p:nvSpPr>
-        <p:spPr>
-          <a:xfrm>
-            <a:off x="4200525" y="933450"/>
-            <a:ext cx="1476375" cy="466725"/>
-          </a:xfrm>
-          <a:prstGeom prst="roundRect">
-            <a:avLst/>
-          </a:prstGeom>
-          <a:solidFill>
-            <a:schemeClr val="accent6">
-              <a:lumMod val="20000"/>
-              <a:lumOff val="80000"/>
-            </a:schemeClr>
-          </a:solidFill>
-          <a:ln>
-            <a:solidFill>
-              <a:schemeClr val="accent6">
-                <a:lumMod val="40000"/>
-                <a:lumOff val="60000"/>
-              </a:schemeClr>
-            </a:solidFill>
-          </a:ln>
-        </p:spPr>
-        <p:style>
-          <a:lnRef idx="2">
-            <a:schemeClr val="accent1">
-              <a:shade val="15000"/>
-            </a:schemeClr>
-          </a:lnRef>
-          <a:fillRef idx="1">
-            <a:schemeClr val="accent1"/>
-          </a:fillRef>
-          <a:effectRef idx="0">
-            <a:schemeClr val="accent1"/>
-          </a:effectRef>
-          <a:fontRef idx="minor">
-            <a:schemeClr val="lt1"/>
-          </a:fontRef>
-        </p:style>
-        <p:txBody>
-          <a:bodyPr rtlCol="0" anchor="ctr"/>
-          <a:lstStyle/>
-          <a:p>
-            <a:pPr algn="ctr"/>
-            <a:r>
-              <a:rPr lang="en-US" altLang="ko-KR" sz="800" b="1" dirty="0">
-                <a:solidFill>
-                  <a:schemeClr val="tx1"/>
-                </a:solidFill>
-              </a:rPr>
-              <a:t>Hybrid Temporal Encoder</a:t>
-            </a:r>
-          </a:p>
-          <a:p>
-            <a:pPr algn="ctr"/>
-            <a:r>
-              <a:rPr lang="en-US" altLang="ko-KR" sz="800" b="1" dirty="0">
-                <a:solidFill>
-                  <a:schemeClr val="tx1"/>
-                </a:solidFill>
-              </a:rPr>
-              <a:t>(Transformer + Mamba)</a:t>
-            </a:r>
-            <a:endParaRPr lang="ko-KR" altLang="en-US" sz="800" b="1" dirty="0">
-              <a:solidFill>
-                <a:schemeClr val="tx1"/>
-              </a:solidFill>
-            </a:endParaRPr>
-          </a:p>
-        </p:txBody>
-      </p:sp>
-      <p:cxnSp>
-        <p:nvCxnSpPr>
-          <p:cNvPr id="29" name="직선 화살표 연결선 28">
-            <a:extLst>
-              <a:ext uri="{FF2B5EF4-FFF2-40B4-BE49-F238E27FC236}">
-                <a16:creationId xmlns:a16="http://schemas.microsoft.com/office/drawing/2014/main" id="{8D3B6B95-FD41-6AD8-3922-8DA1F8DE710D}"/>
-              </a:ext>
-            </a:extLst>
-          </p:cNvPr>
-          <p:cNvCxnSpPr>
-            <a:cxnSpLocks/>
-            <a:endCxn id="30" idx="1"/>
-          </p:cNvCxnSpPr>
-          <p:nvPr/>
-        </p:nvCxnSpPr>
-        <p:spPr>
-          <a:xfrm flipV="1">
-            <a:off x="5694681" y="1166813"/>
-            <a:ext cx="393699" cy="2098"/>
-          </a:xfrm>
-          <a:prstGeom prst="straightConnector1">
-            <a:avLst/>
-          </a:prstGeom>
-          <a:ln>
-            <a:tailEnd type="triangle"/>
-          </a:ln>
-        </p:spPr>
-        <p:style>
-          <a:lnRef idx="2">
-            <a:schemeClr val="dk1"/>
-          </a:lnRef>
-          <a:fillRef idx="0">
-            <a:schemeClr val="dk1"/>
-          </a:fillRef>
-          <a:effectRef idx="1">
-            <a:schemeClr val="dk1"/>
-          </a:effectRef>
-          <a:fontRef idx="minor">
-            <a:schemeClr val="tx1"/>
-          </a:fontRef>
-        </p:style>
-      </p:cxnSp>
-      <p:sp>
-        <p:nvSpPr>
-          <p:cNvPr id="30" name="사각형: 둥근 모서리 29">
-            <a:extLst>
-              <a:ext uri="{FF2B5EF4-FFF2-40B4-BE49-F238E27FC236}">
-                <a16:creationId xmlns:a16="http://schemas.microsoft.com/office/drawing/2014/main" id="{73859922-2D6A-A83A-204A-4F7EEC605C9D}"/>
-              </a:ext>
-            </a:extLst>
-          </p:cNvPr>
-          <p:cNvSpPr/>
-          <p:nvPr/>
-        </p:nvSpPr>
-        <p:spPr>
-          <a:xfrm>
-            <a:off x="6088380" y="933450"/>
-            <a:ext cx="1476375" cy="466725"/>
-          </a:xfrm>
-          <a:prstGeom prst="roundRect">
-            <a:avLst/>
-          </a:prstGeom>
-          <a:solidFill>
-            <a:schemeClr val="accent5">
-              <a:lumMod val="20000"/>
-              <a:lumOff val="80000"/>
-            </a:schemeClr>
-          </a:solidFill>
-          <a:ln>
-            <a:solidFill>
-              <a:schemeClr val="accent5">
-                <a:lumMod val="40000"/>
-                <a:lumOff val="60000"/>
-              </a:schemeClr>
-            </a:solidFill>
-          </a:ln>
-        </p:spPr>
-        <p:style>
-          <a:lnRef idx="2">
-            <a:schemeClr val="accent1">
-              <a:shade val="15000"/>
-            </a:schemeClr>
-          </a:lnRef>
-          <a:fillRef idx="1">
-            <a:schemeClr val="accent1"/>
-          </a:fillRef>
-          <a:effectRef idx="0">
-            <a:schemeClr val="accent1"/>
-          </a:effectRef>
-          <a:fontRef idx="minor">
-            <a:schemeClr val="lt1"/>
-          </a:fontRef>
-        </p:style>
-        <p:txBody>
-          <a:bodyPr rtlCol="0" anchor="ctr"/>
-          <a:lstStyle/>
-          <a:p>
-            <a:pPr algn="ctr"/>
-            <a:r>
-              <a:rPr lang="en-US" altLang="ko-KR" sz="800" b="1" dirty="0">
-                <a:solidFill>
-                  <a:schemeClr val="tx1"/>
-                </a:solidFill>
-              </a:rPr>
-              <a:t>Multi-Future Predictor</a:t>
-            </a:r>
-            <a:endParaRPr lang="ko-KR" altLang="en-US" sz="800" b="1" dirty="0">
-              <a:solidFill>
-                <a:schemeClr val="tx1"/>
-              </a:solidFill>
-            </a:endParaRPr>
-          </a:p>
-        </p:txBody>
-      </p:sp>
       <p:grpSp>
         <p:nvGrpSpPr>
-          <p:cNvPr id="42" name="그룹 41">
-            <a:extLst>
-              <a:ext uri="{FF2B5EF4-FFF2-40B4-BE49-F238E27FC236}">
-                <a16:creationId xmlns:a16="http://schemas.microsoft.com/office/drawing/2014/main" id="{1FF63627-5E1F-5666-3840-34426BA157FF}"/>
+          <p:cNvPr id="55" name="그룹 54">
+            <a:extLst>
+              <a:ext uri="{FF2B5EF4-FFF2-40B4-BE49-F238E27FC236}">
+                <a16:creationId xmlns:a16="http://schemas.microsoft.com/office/drawing/2014/main" id="{87B5FF5C-FBD8-3A78-9EB4-249CF13F7044}"/>
               </a:ext>
             </a:extLst>
           </p:cNvPr>
@@ -7497,34 +6955,200 @@
         </p:nvGrpSpPr>
         <p:grpSpPr>
           <a:xfrm>
-            <a:off x="5956300" y="1400175"/>
-            <a:ext cx="1787525" cy="739775"/>
-            <a:chOff x="5981700" y="1489075"/>
-            <a:chExt cx="1787525" cy="739775"/>
+            <a:off x="684361" y="735521"/>
+            <a:ext cx="7484279" cy="3338004"/>
+            <a:chOff x="684361" y="735521"/>
+            <a:chExt cx="7484279" cy="3338004"/>
           </a:xfrm>
         </p:grpSpPr>
+        <p:grpSp>
+          <p:nvGrpSpPr>
+            <p:cNvPr id="15" name="그룹 14">
+              <a:extLst>
+                <a:ext uri="{FF2B5EF4-FFF2-40B4-BE49-F238E27FC236}">
+                  <a16:creationId xmlns:a16="http://schemas.microsoft.com/office/drawing/2014/main" id="{6C7BAE3F-5A40-B6A0-CE7E-3524B40F6F53}"/>
+                </a:ext>
+              </a:extLst>
+            </p:cNvPr>
+            <p:cNvGrpSpPr/>
+            <p:nvPr/>
+          </p:nvGrpSpPr>
+          <p:grpSpPr>
+            <a:xfrm>
+              <a:off x="684361" y="735521"/>
+              <a:ext cx="1246040" cy="769429"/>
+              <a:chOff x="2919560" y="2710371"/>
+              <a:chExt cx="1595063" cy="953579"/>
+            </a:xfrm>
+          </p:grpSpPr>
+          <p:pic>
+            <p:nvPicPr>
+              <p:cNvPr id="5" name="그림 4">
+                <a:extLst>
+                  <a:ext uri="{FF2B5EF4-FFF2-40B4-BE49-F238E27FC236}">
+                    <a16:creationId xmlns:a16="http://schemas.microsoft.com/office/drawing/2014/main" id="{C8B74491-5E85-23C6-5BF6-E9A6E557742B}"/>
+                  </a:ext>
+                </a:extLst>
+              </p:cNvPr>
+              <p:cNvPicPr>
+                <a:picLocks noChangeAspect="1"/>
+              </p:cNvPicPr>
+              <p:nvPr/>
+            </p:nvPicPr>
+            <p:blipFill>
+              <a:blip r:embed="rId2"/>
+              <a:stretch>
+                <a:fillRect/>
+              </a:stretch>
+            </p:blipFill>
+            <p:spPr>
+              <a:xfrm>
+                <a:off x="2919560" y="2710371"/>
+                <a:ext cx="1480763" cy="832929"/>
+              </a:xfrm>
+              <a:prstGeom prst="rect">
+                <a:avLst/>
+              </a:prstGeom>
+              <a:ln>
+                <a:solidFill>
+                  <a:schemeClr val="tx1"/>
+                </a:solidFill>
+              </a:ln>
+            </p:spPr>
+          </p:pic>
+          <p:pic>
+            <p:nvPicPr>
+              <p:cNvPr id="6" name="그림 5">
+                <a:extLst>
+                  <a:ext uri="{FF2B5EF4-FFF2-40B4-BE49-F238E27FC236}">
+                    <a16:creationId xmlns:a16="http://schemas.microsoft.com/office/drawing/2014/main" id="{F8DBCCB7-036E-921D-EB95-0DF3975132A4}"/>
+                  </a:ext>
+                </a:extLst>
+              </p:cNvPr>
+              <p:cNvPicPr>
+                <a:picLocks noChangeAspect="1"/>
+              </p:cNvPicPr>
+              <p:nvPr/>
+            </p:nvPicPr>
+            <p:blipFill>
+              <a:blip r:embed="rId2"/>
+              <a:stretch>
+                <a:fillRect/>
+              </a:stretch>
+            </p:blipFill>
+            <p:spPr>
+              <a:xfrm>
+                <a:off x="2951310" y="2742121"/>
+                <a:ext cx="1480763" cy="832929"/>
+              </a:xfrm>
+              <a:prstGeom prst="rect">
+                <a:avLst/>
+              </a:prstGeom>
+              <a:ln>
+                <a:solidFill>
+                  <a:schemeClr val="tx1"/>
+                </a:solidFill>
+              </a:ln>
+            </p:spPr>
+          </p:pic>
+          <p:pic>
+            <p:nvPicPr>
+              <p:cNvPr id="7" name="그림 6">
+                <a:extLst>
+                  <a:ext uri="{FF2B5EF4-FFF2-40B4-BE49-F238E27FC236}">
+                    <a16:creationId xmlns:a16="http://schemas.microsoft.com/office/drawing/2014/main" id="{4359A7F3-2B0B-D445-81C6-149CDCD75235}"/>
+                  </a:ext>
+                </a:extLst>
+              </p:cNvPr>
+              <p:cNvPicPr>
+                <a:picLocks noChangeAspect="1"/>
+              </p:cNvPicPr>
+              <p:nvPr/>
+            </p:nvPicPr>
+            <p:blipFill>
+              <a:blip r:embed="rId2"/>
+              <a:stretch>
+                <a:fillRect/>
+              </a:stretch>
+            </p:blipFill>
+            <p:spPr>
+              <a:xfrm>
+                <a:off x="2989410" y="2786571"/>
+                <a:ext cx="1480763" cy="832929"/>
+              </a:xfrm>
+              <a:prstGeom prst="rect">
+                <a:avLst/>
+              </a:prstGeom>
+              <a:ln>
+                <a:solidFill>
+                  <a:schemeClr val="tx1"/>
+                </a:solidFill>
+              </a:ln>
+            </p:spPr>
+          </p:pic>
+          <p:pic>
+            <p:nvPicPr>
+              <p:cNvPr id="8" name="그림 7">
+                <a:extLst>
+                  <a:ext uri="{FF2B5EF4-FFF2-40B4-BE49-F238E27FC236}">
+                    <a16:creationId xmlns:a16="http://schemas.microsoft.com/office/drawing/2014/main" id="{97D45795-BE01-65FC-D3C8-5028447DA7E4}"/>
+                  </a:ext>
+                </a:extLst>
+              </p:cNvPr>
+              <p:cNvPicPr>
+                <a:picLocks noChangeAspect="1"/>
+              </p:cNvPicPr>
+              <p:nvPr/>
+            </p:nvPicPr>
+            <p:blipFill>
+              <a:blip r:embed="rId2"/>
+              <a:stretch>
+                <a:fillRect/>
+              </a:stretch>
+            </p:blipFill>
+            <p:spPr>
+              <a:xfrm>
+                <a:off x="3033860" y="2831021"/>
+                <a:ext cx="1480763" cy="832929"/>
+              </a:xfrm>
+              <a:prstGeom prst="rect">
+                <a:avLst/>
+              </a:prstGeom>
+              <a:ln>
+                <a:solidFill>
+                  <a:schemeClr val="tx1"/>
+                </a:solidFill>
+              </a:ln>
+            </p:spPr>
+          </p:pic>
+        </p:grpSp>
         <p:cxnSp>
           <p:nvCxnSpPr>
-            <p:cNvPr id="36" name="직선 연결선 35">
+            <p:cNvPr id="21" name="직선 화살표 연결선 20">
               <a:extLst>
                 <a:ext uri="{FF2B5EF4-FFF2-40B4-BE49-F238E27FC236}">
-                  <a16:creationId xmlns:a16="http://schemas.microsoft.com/office/drawing/2014/main" id="{3938F86D-2479-75A9-37B9-3012D941FFEE}"/>
+                  <a16:creationId xmlns:a16="http://schemas.microsoft.com/office/drawing/2014/main" id="{045EFB69-B97D-7AA0-D2AF-DDE4A65C9E73}"/>
                 </a:ext>
               </a:extLst>
             </p:cNvPr>
             <p:cNvCxnSpPr>
               <a:cxnSpLocks/>
+              <a:stCxn id="8" idx="3"/>
+              <a:endCxn id="25" idx="1"/>
             </p:cNvCxnSpPr>
             <p:nvPr/>
           </p:nvCxnSpPr>
           <p:spPr>
-            <a:xfrm>
-              <a:off x="5981700" y="1733550"/>
-              <a:ext cx="1787525" cy="0"/>
+            <a:xfrm flipV="1">
+              <a:off x="1930401" y="1166813"/>
+              <a:ext cx="393699" cy="2098"/>
             </a:xfrm>
-            <a:prstGeom prst="line">
+            <a:prstGeom prst="straightConnector1">
               <a:avLst/>
             </a:prstGeom>
+            <a:ln>
+              <a:tailEnd type="triangle"/>
+            </a:ln>
           </p:spPr>
           <p:style>
             <a:lnRef idx="2">
@@ -7541,22 +7165,876 @@
             </a:fontRef>
           </p:style>
         </p:cxnSp>
-        <p:cxnSp>
-          <p:nvCxnSpPr>
-            <p:cNvPr id="38" name="직선 화살표 연결선 37">
+        <p:sp>
+          <p:nvSpPr>
+            <p:cNvPr id="25" name="사각형: 둥근 모서리 24">
               <a:extLst>
                 <a:ext uri="{FF2B5EF4-FFF2-40B4-BE49-F238E27FC236}">
-                  <a16:creationId xmlns:a16="http://schemas.microsoft.com/office/drawing/2014/main" id="{5C33ADC7-AEAD-2666-F424-DC0B683430A3}"/>
+                  <a16:creationId xmlns:a16="http://schemas.microsoft.com/office/drawing/2014/main" id="{1E29B1E4-15D5-6A4C-47C7-888103F5736F}"/>
                 </a:ext>
               </a:extLst>
             </p:cNvPr>
-            <p:cNvCxnSpPr/>
+            <p:cNvSpPr/>
+            <p:nvPr/>
+          </p:nvSpPr>
+          <p:spPr>
+            <a:xfrm>
+              <a:off x="2324100" y="933450"/>
+              <a:ext cx="1476375" cy="466725"/>
+            </a:xfrm>
+            <a:prstGeom prst="roundRect">
+              <a:avLst/>
+            </a:prstGeom>
+            <a:solidFill>
+              <a:schemeClr val="accent1">
+                <a:lumMod val="20000"/>
+                <a:lumOff val="80000"/>
+              </a:schemeClr>
+            </a:solidFill>
+            <a:ln>
+              <a:solidFill>
+                <a:schemeClr val="tx2">
+                  <a:lumMod val="25000"/>
+                  <a:lumOff val="75000"/>
+                </a:schemeClr>
+              </a:solidFill>
+            </a:ln>
+          </p:spPr>
+          <p:style>
+            <a:lnRef idx="2">
+              <a:schemeClr val="accent1">
+                <a:shade val="15000"/>
+              </a:schemeClr>
+            </a:lnRef>
+            <a:fillRef idx="1">
+              <a:schemeClr val="accent1"/>
+            </a:fillRef>
+            <a:effectRef idx="0">
+              <a:schemeClr val="accent1"/>
+            </a:effectRef>
+            <a:fontRef idx="minor">
+              <a:schemeClr val="lt1"/>
+            </a:fontRef>
+          </p:style>
+          <p:txBody>
+            <a:bodyPr rtlCol="0" anchor="ctr"/>
+            <a:lstStyle/>
+            <a:p>
+              <a:pPr algn="ctr"/>
+              <a:r>
+                <a:rPr lang="en-US" altLang="ko-KR" sz="1050" b="1" dirty="0">
+                  <a:solidFill>
+                    <a:schemeClr val="tx1"/>
+                  </a:solidFill>
+                </a:rPr>
+                <a:t>Spatial Backbone</a:t>
+              </a:r>
+            </a:p>
+            <a:p>
+              <a:pPr algn="ctr"/>
+              <a:r>
+                <a:rPr lang="en-US" altLang="ko-KR" sz="1050" b="1" dirty="0">
+                  <a:solidFill>
+                    <a:schemeClr val="tx1"/>
+                  </a:solidFill>
+                </a:rPr>
+                <a:t>(</a:t>
+              </a:r>
+              <a:r>
+                <a:rPr lang="en-US" altLang="ko-KR" sz="1050" b="1" dirty="0" err="1">
+                  <a:solidFill>
+                    <a:schemeClr val="tx1"/>
+                  </a:solidFill>
+                </a:rPr>
+                <a:t>ConvNeXt</a:t>
+              </a:r>
+              <a:r>
+                <a:rPr lang="en-US" altLang="ko-KR" sz="1050" b="1" dirty="0">
+                  <a:solidFill>
+                    <a:schemeClr val="tx1"/>
+                  </a:solidFill>
+                </a:rPr>
+                <a:t> V2)</a:t>
+              </a:r>
+              <a:endParaRPr lang="ko-KR" altLang="en-US" sz="1050" b="1" dirty="0">
+                <a:solidFill>
+                  <a:schemeClr val="tx1"/>
+                </a:solidFill>
+              </a:endParaRPr>
+            </a:p>
+          </p:txBody>
+        </p:sp>
+        <p:cxnSp>
+          <p:nvCxnSpPr>
+            <p:cNvPr id="27" name="직선 화살표 연결선 26">
+              <a:extLst>
+                <a:ext uri="{FF2B5EF4-FFF2-40B4-BE49-F238E27FC236}">
+                  <a16:creationId xmlns:a16="http://schemas.microsoft.com/office/drawing/2014/main" id="{19F8D02C-A6D4-F4DF-21D3-9465FC567C12}"/>
+                </a:ext>
+              </a:extLst>
+            </p:cNvPr>
+            <p:cNvCxnSpPr>
+              <a:cxnSpLocks/>
+              <a:endCxn id="28" idx="1"/>
+            </p:cNvCxnSpPr>
             <p:nvPr/>
           </p:nvCxnSpPr>
           <p:spPr>
+            <a:xfrm flipV="1">
+              <a:off x="3806826" y="1166813"/>
+              <a:ext cx="393699" cy="2098"/>
+            </a:xfrm>
+            <a:prstGeom prst="straightConnector1">
+              <a:avLst/>
+            </a:prstGeom>
+            <a:ln>
+              <a:tailEnd type="triangle"/>
+            </a:ln>
+          </p:spPr>
+          <p:style>
+            <a:lnRef idx="2">
+              <a:schemeClr val="dk1"/>
+            </a:lnRef>
+            <a:fillRef idx="0">
+              <a:schemeClr val="dk1"/>
+            </a:fillRef>
+            <a:effectRef idx="1">
+              <a:schemeClr val="dk1"/>
+            </a:effectRef>
+            <a:fontRef idx="minor">
+              <a:schemeClr val="tx1"/>
+            </a:fontRef>
+          </p:style>
+        </p:cxnSp>
+        <p:sp>
+          <p:nvSpPr>
+            <p:cNvPr id="28" name="사각형: 둥근 모서리 27">
+              <a:extLst>
+                <a:ext uri="{FF2B5EF4-FFF2-40B4-BE49-F238E27FC236}">
+                  <a16:creationId xmlns:a16="http://schemas.microsoft.com/office/drawing/2014/main" id="{6E556030-9809-4B16-4789-B5037AEAEF14}"/>
+                </a:ext>
+              </a:extLst>
+            </p:cNvPr>
+            <p:cNvSpPr/>
+            <p:nvPr/>
+          </p:nvSpPr>
+          <p:spPr>
             <a:xfrm>
-              <a:off x="5994400" y="1739900"/>
-              <a:ext cx="0" cy="488950"/>
+              <a:off x="4200525" y="933450"/>
+              <a:ext cx="1476375" cy="466725"/>
+            </a:xfrm>
+            <a:prstGeom prst="roundRect">
+              <a:avLst/>
+            </a:prstGeom>
+            <a:solidFill>
+              <a:schemeClr val="accent6">
+                <a:lumMod val="20000"/>
+                <a:lumOff val="80000"/>
+              </a:schemeClr>
+            </a:solidFill>
+            <a:ln>
+              <a:solidFill>
+                <a:schemeClr val="accent6">
+                  <a:lumMod val="40000"/>
+                  <a:lumOff val="60000"/>
+                </a:schemeClr>
+              </a:solidFill>
+            </a:ln>
+          </p:spPr>
+          <p:style>
+            <a:lnRef idx="2">
+              <a:schemeClr val="accent1">
+                <a:shade val="15000"/>
+              </a:schemeClr>
+            </a:lnRef>
+            <a:fillRef idx="1">
+              <a:schemeClr val="accent1"/>
+            </a:fillRef>
+            <a:effectRef idx="0">
+              <a:schemeClr val="accent1"/>
+            </a:effectRef>
+            <a:fontRef idx="minor">
+              <a:schemeClr val="lt1"/>
+            </a:fontRef>
+          </p:style>
+          <p:txBody>
+            <a:bodyPr rtlCol="0" anchor="ctr"/>
+            <a:lstStyle/>
+            <a:p>
+              <a:pPr algn="ctr"/>
+              <a:r>
+                <a:rPr lang="en-US" altLang="ko-KR" sz="800" b="1" dirty="0">
+                  <a:solidFill>
+                    <a:schemeClr val="tx1"/>
+                  </a:solidFill>
+                </a:rPr>
+                <a:t>Hybrid Temporal Encoder</a:t>
+              </a:r>
+            </a:p>
+            <a:p>
+              <a:pPr algn="ctr"/>
+              <a:r>
+                <a:rPr lang="en-US" altLang="ko-KR" sz="800" b="1" dirty="0">
+                  <a:solidFill>
+                    <a:schemeClr val="tx1"/>
+                  </a:solidFill>
+                </a:rPr>
+                <a:t>(Transformer + Mamba)</a:t>
+              </a:r>
+              <a:endParaRPr lang="ko-KR" altLang="en-US" sz="800" b="1" dirty="0">
+                <a:solidFill>
+                  <a:schemeClr val="tx1"/>
+                </a:solidFill>
+              </a:endParaRPr>
+            </a:p>
+          </p:txBody>
+        </p:sp>
+        <p:cxnSp>
+          <p:nvCxnSpPr>
+            <p:cNvPr id="29" name="직선 화살표 연결선 28">
+              <a:extLst>
+                <a:ext uri="{FF2B5EF4-FFF2-40B4-BE49-F238E27FC236}">
+                  <a16:creationId xmlns:a16="http://schemas.microsoft.com/office/drawing/2014/main" id="{8D3B6B95-FD41-6AD8-3922-8DA1F8DE710D}"/>
+                </a:ext>
+              </a:extLst>
+            </p:cNvPr>
+            <p:cNvCxnSpPr>
+              <a:cxnSpLocks/>
+              <a:endCxn id="30" idx="1"/>
+            </p:cNvCxnSpPr>
+            <p:nvPr/>
+          </p:nvCxnSpPr>
+          <p:spPr>
+            <a:xfrm flipV="1">
+              <a:off x="5694681" y="1166813"/>
+              <a:ext cx="393699" cy="2098"/>
+            </a:xfrm>
+            <a:prstGeom prst="straightConnector1">
+              <a:avLst/>
+            </a:prstGeom>
+            <a:ln>
+              <a:tailEnd type="triangle"/>
+            </a:ln>
+          </p:spPr>
+          <p:style>
+            <a:lnRef idx="2">
+              <a:schemeClr val="dk1"/>
+            </a:lnRef>
+            <a:fillRef idx="0">
+              <a:schemeClr val="dk1"/>
+            </a:fillRef>
+            <a:effectRef idx="1">
+              <a:schemeClr val="dk1"/>
+            </a:effectRef>
+            <a:fontRef idx="minor">
+              <a:schemeClr val="tx1"/>
+            </a:fontRef>
+          </p:style>
+        </p:cxnSp>
+        <p:sp>
+          <p:nvSpPr>
+            <p:cNvPr id="30" name="사각형: 둥근 모서리 29">
+              <a:extLst>
+                <a:ext uri="{FF2B5EF4-FFF2-40B4-BE49-F238E27FC236}">
+                  <a16:creationId xmlns:a16="http://schemas.microsoft.com/office/drawing/2014/main" id="{73859922-2D6A-A83A-204A-4F7EEC605C9D}"/>
+                </a:ext>
+              </a:extLst>
+            </p:cNvPr>
+            <p:cNvSpPr/>
+            <p:nvPr/>
+          </p:nvSpPr>
+          <p:spPr>
+            <a:xfrm>
+              <a:off x="6088380" y="933450"/>
+              <a:ext cx="1476375" cy="466725"/>
+            </a:xfrm>
+            <a:prstGeom prst="roundRect">
+              <a:avLst/>
+            </a:prstGeom>
+            <a:solidFill>
+              <a:schemeClr val="accent5">
+                <a:lumMod val="20000"/>
+                <a:lumOff val="80000"/>
+              </a:schemeClr>
+            </a:solidFill>
+            <a:ln>
+              <a:solidFill>
+                <a:schemeClr val="accent5">
+                  <a:lumMod val="40000"/>
+                  <a:lumOff val="60000"/>
+                </a:schemeClr>
+              </a:solidFill>
+            </a:ln>
+          </p:spPr>
+          <p:style>
+            <a:lnRef idx="2">
+              <a:schemeClr val="accent1">
+                <a:shade val="15000"/>
+              </a:schemeClr>
+            </a:lnRef>
+            <a:fillRef idx="1">
+              <a:schemeClr val="accent1"/>
+            </a:fillRef>
+            <a:effectRef idx="0">
+              <a:schemeClr val="accent1"/>
+            </a:effectRef>
+            <a:fontRef idx="minor">
+              <a:schemeClr val="lt1"/>
+            </a:fontRef>
+          </p:style>
+          <p:txBody>
+            <a:bodyPr rtlCol="0" anchor="ctr"/>
+            <a:lstStyle/>
+            <a:p>
+              <a:pPr algn="ctr"/>
+              <a:r>
+                <a:rPr lang="en-US" altLang="ko-KR" sz="800" b="1" dirty="0">
+                  <a:solidFill>
+                    <a:schemeClr val="tx1"/>
+                  </a:solidFill>
+                </a:rPr>
+                <a:t>Multi-Future Predictor</a:t>
+              </a:r>
+              <a:endParaRPr lang="ko-KR" altLang="en-US" sz="800" b="1" dirty="0">
+                <a:solidFill>
+                  <a:schemeClr val="tx1"/>
+                </a:solidFill>
+              </a:endParaRPr>
+            </a:p>
+          </p:txBody>
+        </p:sp>
+        <p:grpSp>
+          <p:nvGrpSpPr>
+            <p:cNvPr id="42" name="그룹 41">
+              <a:extLst>
+                <a:ext uri="{FF2B5EF4-FFF2-40B4-BE49-F238E27FC236}">
+                  <a16:creationId xmlns:a16="http://schemas.microsoft.com/office/drawing/2014/main" id="{1FF63627-5E1F-5666-3840-34426BA157FF}"/>
+                </a:ext>
+              </a:extLst>
+            </p:cNvPr>
+            <p:cNvGrpSpPr/>
+            <p:nvPr/>
+          </p:nvGrpSpPr>
+          <p:grpSpPr>
+            <a:xfrm>
+              <a:off x="5956300" y="1400175"/>
+              <a:ext cx="1787525" cy="739775"/>
+              <a:chOff x="5981700" y="1489075"/>
+              <a:chExt cx="1787525" cy="739775"/>
+            </a:xfrm>
+          </p:grpSpPr>
+          <p:cxnSp>
+            <p:nvCxnSpPr>
+              <p:cNvPr id="36" name="직선 연결선 35">
+                <a:extLst>
+                  <a:ext uri="{FF2B5EF4-FFF2-40B4-BE49-F238E27FC236}">
+                    <a16:creationId xmlns:a16="http://schemas.microsoft.com/office/drawing/2014/main" id="{3938F86D-2479-75A9-37B9-3012D941FFEE}"/>
+                  </a:ext>
+                </a:extLst>
+              </p:cNvPr>
+              <p:cNvCxnSpPr>
+                <a:cxnSpLocks/>
+              </p:cNvCxnSpPr>
+              <p:nvPr/>
+            </p:nvCxnSpPr>
+            <p:spPr>
+              <a:xfrm>
+                <a:off x="5981700" y="1733550"/>
+                <a:ext cx="1787525" cy="0"/>
+              </a:xfrm>
+              <a:prstGeom prst="line">
+                <a:avLst/>
+              </a:prstGeom>
+            </p:spPr>
+            <p:style>
+              <a:lnRef idx="2">
+                <a:schemeClr val="dk1"/>
+              </a:lnRef>
+              <a:fillRef idx="0">
+                <a:schemeClr val="dk1"/>
+              </a:fillRef>
+              <a:effectRef idx="1">
+                <a:schemeClr val="dk1"/>
+              </a:effectRef>
+              <a:fontRef idx="minor">
+                <a:schemeClr val="tx1"/>
+              </a:fontRef>
+            </p:style>
+          </p:cxnSp>
+          <p:cxnSp>
+            <p:nvCxnSpPr>
+              <p:cNvPr id="38" name="직선 화살표 연결선 37">
+                <a:extLst>
+                  <a:ext uri="{FF2B5EF4-FFF2-40B4-BE49-F238E27FC236}">
+                    <a16:creationId xmlns:a16="http://schemas.microsoft.com/office/drawing/2014/main" id="{5C33ADC7-AEAD-2666-F424-DC0B683430A3}"/>
+                  </a:ext>
+                </a:extLst>
+              </p:cNvPr>
+              <p:cNvCxnSpPr/>
+              <p:nvPr/>
+            </p:nvCxnSpPr>
+            <p:spPr>
+              <a:xfrm>
+                <a:off x="5994400" y="1739900"/>
+                <a:ext cx="0" cy="488950"/>
+              </a:xfrm>
+              <a:prstGeom prst="straightConnector1">
+                <a:avLst/>
+              </a:prstGeom>
+              <a:ln>
+                <a:tailEnd type="triangle"/>
+              </a:ln>
+            </p:spPr>
+            <p:style>
+              <a:lnRef idx="2">
+                <a:schemeClr val="dk1"/>
+              </a:lnRef>
+              <a:fillRef idx="0">
+                <a:schemeClr val="dk1"/>
+              </a:fillRef>
+              <a:effectRef idx="1">
+                <a:schemeClr val="dk1"/>
+              </a:effectRef>
+              <a:fontRef idx="minor">
+                <a:schemeClr val="tx1"/>
+              </a:fontRef>
+            </p:style>
+          </p:cxnSp>
+          <p:cxnSp>
+            <p:nvCxnSpPr>
+              <p:cNvPr id="39" name="직선 화살표 연결선 38">
+                <a:extLst>
+                  <a:ext uri="{FF2B5EF4-FFF2-40B4-BE49-F238E27FC236}">
+                    <a16:creationId xmlns:a16="http://schemas.microsoft.com/office/drawing/2014/main" id="{CA306652-1749-7BDC-89EA-B8B067F3D3DD}"/>
+                  </a:ext>
+                </a:extLst>
+              </p:cNvPr>
+              <p:cNvCxnSpPr>
+                <a:cxnSpLocks/>
+                <a:stCxn id="30" idx="2"/>
+              </p:cNvCxnSpPr>
+              <p:nvPr/>
+            </p:nvCxnSpPr>
+            <p:spPr>
+              <a:xfrm flipH="1">
+                <a:off x="6851650" y="1489075"/>
+                <a:ext cx="318" cy="739775"/>
+              </a:xfrm>
+              <a:prstGeom prst="straightConnector1">
+                <a:avLst/>
+              </a:prstGeom>
+              <a:ln>
+                <a:tailEnd type="triangle"/>
+              </a:ln>
+            </p:spPr>
+            <p:style>
+              <a:lnRef idx="2">
+                <a:schemeClr val="dk1"/>
+              </a:lnRef>
+              <a:fillRef idx="0">
+                <a:schemeClr val="dk1"/>
+              </a:fillRef>
+              <a:effectRef idx="1">
+                <a:schemeClr val="dk1"/>
+              </a:effectRef>
+              <a:fontRef idx="minor">
+                <a:schemeClr val="tx1"/>
+              </a:fontRef>
+            </p:style>
+          </p:cxnSp>
+          <p:cxnSp>
+            <p:nvCxnSpPr>
+              <p:cNvPr id="40" name="직선 화살표 연결선 39">
+                <a:extLst>
+                  <a:ext uri="{FF2B5EF4-FFF2-40B4-BE49-F238E27FC236}">
+                    <a16:creationId xmlns:a16="http://schemas.microsoft.com/office/drawing/2014/main" id="{2AC931CF-9B60-63D0-7D8A-718AE188AA01}"/>
+                  </a:ext>
+                </a:extLst>
+              </p:cNvPr>
+              <p:cNvCxnSpPr/>
+              <p:nvPr/>
+            </p:nvCxnSpPr>
+            <p:spPr>
+              <a:xfrm>
+                <a:off x="7759700" y="1739900"/>
+                <a:ext cx="0" cy="488950"/>
+              </a:xfrm>
+              <a:prstGeom prst="straightConnector1">
+                <a:avLst/>
+              </a:prstGeom>
+              <a:ln>
+                <a:tailEnd type="triangle"/>
+              </a:ln>
+            </p:spPr>
+            <p:style>
+              <a:lnRef idx="2">
+                <a:schemeClr val="dk1"/>
+              </a:lnRef>
+              <a:fillRef idx="0">
+                <a:schemeClr val="dk1"/>
+              </a:fillRef>
+              <a:effectRef idx="1">
+                <a:schemeClr val="dk1"/>
+              </a:effectRef>
+              <a:fontRef idx="minor">
+                <a:schemeClr val="tx1"/>
+              </a:fontRef>
+            </p:style>
+          </p:cxnSp>
+        </p:grpSp>
+        <p:sp>
+          <p:nvSpPr>
+            <p:cNvPr id="43" name="TextBox 42">
+              <a:extLst>
+                <a:ext uri="{FF2B5EF4-FFF2-40B4-BE49-F238E27FC236}">
+                  <a16:creationId xmlns:a16="http://schemas.microsoft.com/office/drawing/2014/main" id="{619367E7-1186-9FAD-1005-64151760D412}"/>
+                </a:ext>
+              </a:extLst>
+            </p:cNvPr>
+            <p:cNvSpPr txBox="1"/>
+            <p:nvPr/>
+          </p:nvSpPr>
+          <p:spPr>
+            <a:xfrm>
+              <a:off x="6417734" y="2146301"/>
+              <a:ext cx="799450" cy="276999"/>
+            </a:xfrm>
+            <a:prstGeom prst="rect">
+              <a:avLst/>
+            </a:prstGeom>
+            <a:noFill/>
+          </p:spPr>
+          <p:txBody>
+            <a:bodyPr wrap="none" rtlCol="0">
+              <a:spAutoFit/>
+            </a:bodyPr>
+            <a:lstStyle/>
+            <a:p>
+              <a:r>
+                <a:rPr lang="en-US" altLang="ko-KR" sz="1200" b="1" dirty="0"/>
+                <a:t>Future 2</a:t>
+              </a:r>
+              <a:endParaRPr lang="ko-KR" altLang="en-US" sz="1200" b="1" dirty="0"/>
+            </a:p>
+          </p:txBody>
+        </p:sp>
+        <p:sp>
+          <p:nvSpPr>
+            <p:cNvPr id="44" name="TextBox 43">
+              <a:extLst>
+                <a:ext uri="{FF2B5EF4-FFF2-40B4-BE49-F238E27FC236}">
+                  <a16:creationId xmlns:a16="http://schemas.microsoft.com/office/drawing/2014/main" id="{0454A96D-7EE4-93CC-C9EA-68AE1520F6AF}"/>
+                </a:ext>
+              </a:extLst>
+            </p:cNvPr>
+            <p:cNvSpPr txBox="1"/>
+            <p:nvPr/>
+          </p:nvSpPr>
+          <p:spPr>
+            <a:xfrm>
+              <a:off x="5575301" y="2146301"/>
+              <a:ext cx="799450" cy="276999"/>
+            </a:xfrm>
+            <a:prstGeom prst="rect">
+              <a:avLst/>
+            </a:prstGeom>
+            <a:noFill/>
+          </p:spPr>
+          <p:txBody>
+            <a:bodyPr wrap="none" rtlCol="0">
+              <a:spAutoFit/>
+            </a:bodyPr>
+            <a:lstStyle/>
+            <a:p>
+              <a:r>
+                <a:rPr lang="en-US" altLang="ko-KR" sz="1200" b="1" dirty="0"/>
+                <a:t>Future 1</a:t>
+              </a:r>
+              <a:endParaRPr lang="ko-KR" altLang="en-US" sz="1200" b="1" dirty="0"/>
+            </a:p>
+          </p:txBody>
+        </p:sp>
+        <p:sp>
+          <p:nvSpPr>
+            <p:cNvPr id="45" name="TextBox 44">
+              <a:extLst>
+                <a:ext uri="{FF2B5EF4-FFF2-40B4-BE49-F238E27FC236}">
+                  <a16:creationId xmlns:a16="http://schemas.microsoft.com/office/drawing/2014/main" id="{8DB1EDBA-10DF-000D-70A0-7B293A1754DA}"/>
+                </a:ext>
+              </a:extLst>
+            </p:cNvPr>
+            <p:cNvSpPr txBox="1"/>
+            <p:nvPr/>
+          </p:nvSpPr>
+          <p:spPr>
+            <a:xfrm>
+              <a:off x="7302501" y="2146301"/>
+              <a:ext cx="809068" cy="276999"/>
+            </a:xfrm>
+            <a:prstGeom prst="rect">
+              <a:avLst/>
+            </a:prstGeom>
+            <a:noFill/>
+          </p:spPr>
+          <p:txBody>
+            <a:bodyPr wrap="none" rtlCol="0">
+              <a:spAutoFit/>
+            </a:bodyPr>
+            <a:lstStyle/>
+            <a:p>
+              <a:r>
+                <a:rPr lang="en-US" altLang="ko-KR" sz="1200" b="1" dirty="0"/>
+                <a:t>Future K</a:t>
+              </a:r>
+              <a:endParaRPr lang="ko-KR" altLang="en-US" sz="1200" b="1" dirty="0"/>
+            </a:p>
+          </p:txBody>
+        </p:sp>
+        <p:cxnSp>
+          <p:nvCxnSpPr>
+            <p:cNvPr id="48" name="직선 화살표 연결선 47">
+              <a:extLst>
+                <a:ext uri="{FF2B5EF4-FFF2-40B4-BE49-F238E27FC236}">
+                  <a16:creationId xmlns:a16="http://schemas.microsoft.com/office/drawing/2014/main" id="{7D8917EC-F118-70C8-55E6-575F9D933F00}"/>
+                </a:ext>
+              </a:extLst>
+            </p:cNvPr>
+            <p:cNvCxnSpPr>
+              <a:cxnSpLocks/>
+              <a:stCxn id="43" idx="2"/>
+            </p:cNvCxnSpPr>
+            <p:nvPr/>
+          </p:nvCxnSpPr>
+          <p:spPr>
+            <a:xfrm flipH="1">
+              <a:off x="6812280" y="2423300"/>
+              <a:ext cx="5179" cy="314820"/>
+            </a:xfrm>
+            <a:prstGeom prst="straightConnector1">
+              <a:avLst/>
+            </a:prstGeom>
+            <a:ln>
+              <a:tailEnd type="triangle"/>
+            </a:ln>
+          </p:spPr>
+          <p:style>
+            <a:lnRef idx="2">
+              <a:schemeClr val="dk1"/>
+            </a:lnRef>
+            <a:fillRef idx="0">
+              <a:schemeClr val="dk1"/>
+            </a:fillRef>
+            <a:effectRef idx="1">
+              <a:schemeClr val="dk1"/>
+            </a:effectRef>
+            <a:fontRef idx="minor">
+              <a:schemeClr val="tx1"/>
+            </a:fontRef>
+          </p:style>
+        </p:cxnSp>
+        <p:sp>
+          <p:nvSpPr>
+            <p:cNvPr id="49" name="사각형: 둥근 모서리 48">
+              <a:extLst>
+                <a:ext uri="{FF2B5EF4-FFF2-40B4-BE49-F238E27FC236}">
+                  <a16:creationId xmlns:a16="http://schemas.microsoft.com/office/drawing/2014/main" id="{F0D9C0F9-DB93-C4BC-8BC1-619EF9D64F20}"/>
+                </a:ext>
+              </a:extLst>
+            </p:cNvPr>
+            <p:cNvSpPr/>
+            <p:nvPr/>
+          </p:nvSpPr>
+          <p:spPr>
+            <a:xfrm>
+              <a:off x="5609168" y="2787650"/>
+              <a:ext cx="2559472" cy="466725"/>
+            </a:xfrm>
+            <a:prstGeom prst="roundRect">
+              <a:avLst/>
+            </a:prstGeom>
+            <a:solidFill>
+              <a:schemeClr val="accent2">
+                <a:lumMod val="20000"/>
+                <a:lumOff val="80000"/>
+              </a:schemeClr>
+            </a:solidFill>
+            <a:ln>
+              <a:solidFill>
+                <a:schemeClr val="accent2">
+                  <a:lumMod val="40000"/>
+                  <a:lumOff val="60000"/>
+                </a:schemeClr>
+              </a:solidFill>
+            </a:ln>
+          </p:spPr>
+          <p:style>
+            <a:lnRef idx="2">
+              <a:schemeClr val="accent1">
+                <a:shade val="15000"/>
+              </a:schemeClr>
+            </a:lnRef>
+            <a:fillRef idx="1">
+              <a:schemeClr val="accent1"/>
+            </a:fillRef>
+            <a:effectRef idx="0">
+              <a:schemeClr val="accent1"/>
+            </a:effectRef>
+            <a:fontRef idx="minor">
+              <a:schemeClr val="lt1"/>
+            </a:fontRef>
+          </p:style>
+          <p:txBody>
+            <a:bodyPr rtlCol="0" anchor="ctr"/>
+            <a:lstStyle/>
+            <a:p>
+              <a:pPr algn="ctr"/>
+              <a:r>
+                <a:rPr lang="en-US" altLang="ko-KR" sz="800" b="1" dirty="0">
+                  <a:solidFill>
+                    <a:schemeClr val="tx1"/>
+                  </a:solidFill>
+                </a:rPr>
+                <a:t>Event / Risk Head</a:t>
+              </a:r>
+              <a:endParaRPr lang="ko-KR" altLang="en-US" sz="800" b="1" dirty="0">
+                <a:solidFill>
+                  <a:schemeClr val="tx1"/>
+                </a:solidFill>
+              </a:endParaRPr>
+            </a:p>
+          </p:txBody>
+        </p:sp>
+        <p:cxnSp>
+          <p:nvCxnSpPr>
+            <p:cNvPr id="50" name="직선 화살표 연결선 49">
+              <a:extLst>
+                <a:ext uri="{FF2B5EF4-FFF2-40B4-BE49-F238E27FC236}">
+                  <a16:creationId xmlns:a16="http://schemas.microsoft.com/office/drawing/2014/main" id="{F4332BF3-6FFA-6068-9FD3-8838901A9E6F}"/>
+                </a:ext>
+              </a:extLst>
+            </p:cNvPr>
+            <p:cNvCxnSpPr>
+              <a:cxnSpLocks/>
+            </p:cNvCxnSpPr>
+            <p:nvPr/>
+          </p:nvCxnSpPr>
+          <p:spPr>
+            <a:xfrm flipH="1">
+              <a:off x="6812280" y="3242450"/>
+              <a:ext cx="5179" cy="314820"/>
+            </a:xfrm>
+            <a:prstGeom prst="straightConnector1">
+              <a:avLst/>
+            </a:prstGeom>
+            <a:ln>
+              <a:tailEnd type="triangle"/>
+            </a:ln>
+          </p:spPr>
+          <p:style>
+            <a:lnRef idx="2">
+              <a:schemeClr val="dk1"/>
+            </a:lnRef>
+            <a:fillRef idx="0">
+              <a:schemeClr val="dk1"/>
+            </a:fillRef>
+            <a:effectRef idx="1">
+              <a:schemeClr val="dk1"/>
+            </a:effectRef>
+            <a:fontRef idx="minor">
+              <a:schemeClr val="tx1"/>
+            </a:fontRef>
+          </p:style>
+        </p:cxnSp>
+        <p:sp>
+          <p:nvSpPr>
+            <p:cNvPr id="51" name="사각형: 둥근 모서리 50">
+              <a:extLst>
+                <a:ext uri="{FF2B5EF4-FFF2-40B4-BE49-F238E27FC236}">
+                  <a16:creationId xmlns:a16="http://schemas.microsoft.com/office/drawing/2014/main" id="{1947358C-9DEE-5439-A29F-38DE92733393}"/>
+                </a:ext>
+              </a:extLst>
+            </p:cNvPr>
+            <p:cNvSpPr/>
+            <p:nvPr/>
+          </p:nvSpPr>
+          <p:spPr>
+            <a:xfrm>
+              <a:off x="6088380" y="3606800"/>
+              <a:ext cx="1476375" cy="466725"/>
+            </a:xfrm>
+            <a:prstGeom prst="roundRect">
+              <a:avLst/>
+            </a:prstGeom>
+            <a:solidFill>
+              <a:schemeClr val="tx2">
+                <a:lumMod val="10000"/>
+                <a:lumOff val="90000"/>
+              </a:schemeClr>
+            </a:solidFill>
+            <a:ln>
+              <a:solidFill>
+                <a:schemeClr val="tx2">
+                  <a:lumMod val="25000"/>
+                  <a:lumOff val="75000"/>
+                </a:schemeClr>
+              </a:solidFill>
+            </a:ln>
+          </p:spPr>
+          <p:style>
+            <a:lnRef idx="2">
+              <a:schemeClr val="accent1">
+                <a:shade val="15000"/>
+              </a:schemeClr>
+            </a:lnRef>
+            <a:fillRef idx="1">
+              <a:schemeClr val="accent1"/>
+            </a:fillRef>
+            <a:effectRef idx="0">
+              <a:schemeClr val="accent1"/>
+            </a:effectRef>
+            <a:fontRef idx="minor">
+              <a:schemeClr val="lt1"/>
+            </a:fontRef>
+          </p:style>
+          <p:txBody>
+            <a:bodyPr rtlCol="0" anchor="ctr"/>
+            <a:lstStyle/>
+            <a:p>
+              <a:pPr algn="ctr"/>
+              <a:r>
+                <a:rPr lang="en-US" altLang="ko-KR" sz="800" b="1" dirty="0">
+                  <a:solidFill>
+                    <a:schemeClr val="tx1"/>
+                  </a:solidFill>
+                </a:rPr>
+                <a:t>Final Safety Prediction</a:t>
+              </a:r>
+              <a:endParaRPr lang="ko-KR" altLang="en-US" sz="800" b="1" dirty="0">
+                <a:solidFill>
+                  <a:schemeClr val="tx1"/>
+                </a:solidFill>
+              </a:endParaRPr>
+            </a:p>
+          </p:txBody>
+        </p:sp>
+        <p:cxnSp>
+          <p:nvCxnSpPr>
+            <p:cNvPr id="52" name="직선 화살표 연결선 51">
+              <a:extLst>
+                <a:ext uri="{FF2B5EF4-FFF2-40B4-BE49-F238E27FC236}">
+                  <a16:creationId xmlns:a16="http://schemas.microsoft.com/office/drawing/2014/main" id="{BD823A5C-B228-EE28-B413-2D4B715A1647}"/>
+                </a:ext>
+              </a:extLst>
+            </p:cNvPr>
+            <p:cNvCxnSpPr>
+              <a:cxnSpLocks/>
+            </p:cNvCxnSpPr>
+            <p:nvPr/>
+          </p:nvCxnSpPr>
+          <p:spPr>
+            <a:xfrm flipH="1">
+              <a:off x="5958840" y="2423300"/>
+              <a:ext cx="5179" cy="314820"/>
             </a:xfrm>
             <a:prstGeom prst="straightConnector1">
               <a:avLst/>
@@ -7582,23 +8060,22 @@
         </p:cxnSp>
         <p:cxnSp>
           <p:nvCxnSpPr>
-            <p:cNvPr id="39" name="직선 화살표 연결선 38">
+            <p:cNvPr id="53" name="직선 화살표 연결선 52">
               <a:extLst>
                 <a:ext uri="{FF2B5EF4-FFF2-40B4-BE49-F238E27FC236}">
-                  <a16:creationId xmlns:a16="http://schemas.microsoft.com/office/drawing/2014/main" id="{CA306652-1749-7BDC-89EA-B8B067F3D3DD}"/>
+                  <a16:creationId xmlns:a16="http://schemas.microsoft.com/office/drawing/2014/main" id="{E473324A-4276-1C65-A2A4-AE2FF765D5D6}"/>
                 </a:ext>
               </a:extLst>
             </p:cNvPr>
             <p:cNvCxnSpPr>
               <a:cxnSpLocks/>
-              <a:stCxn id="30" idx="2"/>
             </p:cNvCxnSpPr>
             <p:nvPr/>
           </p:nvCxnSpPr>
           <p:spPr>
             <a:xfrm flipH="1">
-              <a:off x="6851650" y="1489075"/>
-              <a:ext cx="318" cy="739775"/>
+              <a:off x="7741920" y="2423300"/>
+              <a:ext cx="5179" cy="314820"/>
             </a:xfrm>
             <a:prstGeom prst="straightConnector1">
               <a:avLst/>
@@ -7622,506 +8099,50 @@
             </a:fontRef>
           </p:style>
         </p:cxnSp>
-        <p:cxnSp>
-          <p:nvCxnSpPr>
-            <p:cNvPr id="40" name="직선 화살표 연결선 39">
+        <p:sp>
+          <p:nvSpPr>
+            <p:cNvPr id="54" name="TextBox 53">
               <a:extLst>
                 <a:ext uri="{FF2B5EF4-FFF2-40B4-BE49-F238E27FC236}">
-                  <a16:creationId xmlns:a16="http://schemas.microsoft.com/office/drawing/2014/main" id="{2AC931CF-9B60-63D0-7D8A-718AE188AA01}"/>
+                  <a16:creationId xmlns:a16="http://schemas.microsoft.com/office/drawing/2014/main" id="{54AA53E3-D015-279E-3B64-AD8C04B3B1D0}"/>
                 </a:ext>
               </a:extLst>
             </p:cNvPr>
-            <p:cNvCxnSpPr/>
+            <p:cNvSpPr txBox="1"/>
             <p:nvPr/>
-          </p:nvCxnSpPr>
+          </p:nvSpPr>
           <p:spPr>
             <a:xfrm>
-              <a:off x="7759700" y="1739900"/>
-              <a:ext cx="0" cy="488950"/>
+              <a:off x="918211" y="1544321"/>
+              <a:ext cx="936475" cy="461665"/>
             </a:xfrm>
-            <a:prstGeom prst="straightConnector1">
+            <a:prstGeom prst="rect">
               <a:avLst/>
             </a:prstGeom>
-            <a:ln>
-              <a:tailEnd type="triangle"/>
-            </a:ln>
+            <a:noFill/>
           </p:spPr>
-          <p:style>
-            <a:lnRef idx="2">
-              <a:schemeClr val="dk1"/>
-            </a:lnRef>
-            <a:fillRef idx="0">
-              <a:schemeClr val="dk1"/>
-            </a:fillRef>
-            <a:effectRef idx="1">
-              <a:schemeClr val="dk1"/>
-            </a:effectRef>
-            <a:fontRef idx="minor">
-              <a:schemeClr val="tx1"/>
-            </a:fontRef>
-          </p:style>
-        </p:cxnSp>
+          <p:txBody>
+            <a:bodyPr wrap="none" rtlCol="0">
+              <a:spAutoFit/>
+            </a:bodyPr>
+            <a:lstStyle/>
+            <a:p>
+              <a:r>
+                <a:rPr lang="en-US" altLang="ko-KR" sz="1200" b="1" dirty="0"/>
+                <a:t>Video Clip</a:t>
+              </a:r>
+            </a:p>
+            <a:p>
+              <a:pPr algn="ctr"/>
+              <a:r>
+                <a:rPr lang="en-US" altLang="ko-KR" sz="1200" b="1" dirty="0"/>
+                <a:t>(8 frames)</a:t>
+              </a:r>
+              <a:endParaRPr lang="ko-KR" altLang="en-US" sz="1200" b="1" dirty="0"/>
+            </a:p>
+          </p:txBody>
+        </p:sp>
       </p:grpSp>
-      <p:sp>
-        <p:nvSpPr>
-          <p:cNvPr id="43" name="TextBox 42">
-            <a:extLst>
-              <a:ext uri="{FF2B5EF4-FFF2-40B4-BE49-F238E27FC236}">
-                <a16:creationId xmlns:a16="http://schemas.microsoft.com/office/drawing/2014/main" id="{619367E7-1186-9FAD-1005-64151760D412}"/>
-              </a:ext>
-            </a:extLst>
-          </p:cNvPr>
-          <p:cNvSpPr txBox="1"/>
-          <p:nvPr/>
-        </p:nvSpPr>
-        <p:spPr>
-          <a:xfrm>
-            <a:off x="6417734" y="2146301"/>
-            <a:ext cx="799450" cy="276999"/>
-          </a:xfrm>
-          <a:prstGeom prst="rect">
-            <a:avLst/>
-          </a:prstGeom>
-          <a:noFill/>
-        </p:spPr>
-        <p:txBody>
-          <a:bodyPr wrap="none" rtlCol="0">
-            <a:spAutoFit/>
-          </a:bodyPr>
-          <a:lstStyle/>
-          <a:p>
-            <a:r>
-              <a:rPr lang="en-US" altLang="ko-KR" sz="1200" b="1" dirty="0"/>
-              <a:t>Future 2</a:t>
-            </a:r>
-            <a:endParaRPr lang="ko-KR" altLang="en-US" sz="1200" b="1" dirty="0"/>
-          </a:p>
-        </p:txBody>
-      </p:sp>
-      <p:sp>
-        <p:nvSpPr>
-          <p:cNvPr id="44" name="TextBox 43">
-            <a:extLst>
-              <a:ext uri="{FF2B5EF4-FFF2-40B4-BE49-F238E27FC236}">
-                <a16:creationId xmlns:a16="http://schemas.microsoft.com/office/drawing/2014/main" id="{0454A96D-7EE4-93CC-C9EA-68AE1520F6AF}"/>
-              </a:ext>
-            </a:extLst>
-          </p:cNvPr>
-          <p:cNvSpPr txBox="1"/>
-          <p:nvPr/>
-        </p:nvSpPr>
-        <p:spPr>
-          <a:xfrm>
-            <a:off x="5575301" y="2146301"/>
-            <a:ext cx="799450" cy="276999"/>
-          </a:xfrm>
-          <a:prstGeom prst="rect">
-            <a:avLst/>
-          </a:prstGeom>
-          <a:noFill/>
-        </p:spPr>
-        <p:txBody>
-          <a:bodyPr wrap="none" rtlCol="0">
-            <a:spAutoFit/>
-          </a:bodyPr>
-          <a:lstStyle/>
-          <a:p>
-            <a:r>
-              <a:rPr lang="en-US" altLang="ko-KR" sz="1200" b="1" dirty="0"/>
-              <a:t>Future 1</a:t>
-            </a:r>
-            <a:endParaRPr lang="ko-KR" altLang="en-US" sz="1200" b="1" dirty="0"/>
-          </a:p>
-        </p:txBody>
-      </p:sp>
-      <p:sp>
-        <p:nvSpPr>
-          <p:cNvPr id="45" name="TextBox 44">
-            <a:extLst>
-              <a:ext uri="{FF2B5EF4-FFF2-40B4-BE49-F238E27FC236}">
-                <a16:creationId xmlns:a16="http://schemas.microsoft.com/office/drawing/2014/main" id="{8DB1EDBA-10DF-000D-70A0-7B293A1754DA}"/>
-              </a:ext>
-            </a:extLst>
-          </p:cNvPr>
-          <p:cNvSpPr txBox="1"/>
-          <p:nvPr/>
-        </p:nvSpPr>
-        <p:spPr>
-          <a:xfrm>
-            <a:off x="7302501" y="2146301"/>
-            <a:ext cx="809068" cy="276999"/>
-          </a:xfrm>
-          <a:prstGeom prst="rect">
-            <a:avLst/>
-          </a:prstGeom>
-          <a:noFill/>
-        </p:spPr>
-        <p:txBody>
-          <a:bodyPr wrap="none" rtlCol="0">
-            <a:spAutoFit/>
-          </a:bodyPr>
-          <a:lstStyle/>
-          <a:p>
-            <a:r>
-              <a:rPr lang="en-US" altLang="ko-KR" sz="1200" b="1" dirty="0"/>
-              <a:t>Future K</a:t>
-            </a:r>
-            <a:endParaRPr lang="ko-KR" altLang="en-US" sz="1200" b="1" dirty="0"/>
-          </a:p>
-        </p:txBody>
-      </p:sp>
-      <p:cxnSp>
-        <p:nvCxnSpPr>
-          <p:cNvPr id="48" name="직선 화살표 연결선 47">
-            <a:extLst>
-              <a:ext uri="{FF2B5EF4-FFF2-40B4-BE49-F238E27FC236}">
-                <a16:creationId xmlns:a16="http://schemas.microsoft.com/office/drawing/2014/main" id="{7D8917EC-F118-70C8-55E6-575F9D933F00}"/>
-              </a:ext>
-            </a:extLst>
-          </p:cNvPr>
-          <p:cNvCxnSpPr>
-            <a:cxnSpLocks/>
-            <a:stCxn id="43" idx="2"/>
-          </p:cNvCxnSpPr>
-          <p:nvPr/>
-        </p:nvCxnSpPr>
-        <p:spPr>
-          <a:xfrm flipH="1">
-            <a:off x="6812280" y="2423300"/>
-            <a:ext cx="5179" cy="314820"/>
-          </a:xfrm>
-          <a:prstGeom prst="straightConnector1">
-            <a:avLst/>
-          </a:prstGeom>
-          <a:ln>
-            <a:tailEnd type="triangle"/>
-          </a:ln>
-        </p:spPr>
-        <p:style>
-          <a:lnRef idx="2">
-            <a:schemeClr val="dk1"/>
-          </a:lnRef>
-          <a:fillRef idx="0">
-            <a:schemeClr val="dk1"/>
-          </a:fillRef>
-          <a:effectRef idx="1">
-            <a:schemeClr val="dk1"/>
-          </a:effectRef>
-          <a:fontRef idx="minor">
-            <a:schemeClr val="tx1"/>
-          </a:fontRef>
-        </p:style>
-      </p:cxnSp>
-      <p:sp>
-        <p:nvSpPr>
-          <p:cNvPr id="49" name="사각형: 둥근 모서리 48">
-            <a:extLst>
-              <a:ext uri="{FF2B5EF4-FFF2-40B4-BE49-F238E27FC236}">
-                <a16:creationId xmlns:a16="http://schemas.microsoft.com/office/drawing/2014/main" id="{F0D9C0F9-DB93-C4BC-8BC1-619EF9D64F20}"/>
-              </a:ext>
-            </a:extLst>
-          </p:cNvPr>
-          <p:cNvSpPr/>
-          <p:nvPr/>
-        </p:nvSpPr>
-        <p:spPr>
-          <a:xfrm>
-            <a:off x="5609168" y="2787650"/>
-            <a:ext cx="2559472" cy="466725"/>
-          </a:xfrm>
-          <a:prstGeom prst="roundRect">
-            <a:avLst/>
-          </a:prstGeom>
-          <a:solidFill>
-            <a:schemeClr val="accent2">
-              <a:lumMod val="20000"/>
-              <a:lumOff val="80000"/>
-            </a:schemeClr>
-          </a:solidFill>
-          <a:ln>
-            <a:solidFill>
-              <a:schemeClr val="accent2">
-                <a:lumMod val="40000"/>
-                <a:lumOff val="60000"/>
-              </a:schemeClr>
-            </a:solidFill>
-          </a:ln>
-        </p:spPr>
-        <p:style>
-          <a:lnRef idx="2">
-            <a:schemeClr val="accent1">
-              <a:shade val="15000"/>
-            </a:schemeClr>
-          </a:lnRef>
-          <a:fillRef idx="1">
-            <a:schemeClr val="accent1"/>
-          </a:fillRef>
-          <a:effectRef idx="0">
-            <a:schemeClr val="accent1"/>
-          </a:effectRef>
-          <a:fontRef idx="minor">
-            <a:schemeClr val="lt1"/>
-          </a:fontRef>
-        </p:style>
-        <p:txBody>
-          <a:bodyPr rtlCol="0" anchor="ctr"/>
-          <a:lstStyle/>
-          <a:p>
-            <a:pPr algn="ctr"/>
-            <a:r>
-              <a:rPr lang="en-US" altLang="ko-KR" sz="800" b="1" dirty="0">
-                <a:solidFill>
-                  <a:schemeClr val="tx1"/>
-                </a:solidFill>
-              </a:rPr>
-              <a:t>Event / Risk Head</a:t>
-            </a:r>
-            <a:endParaRPr lang="ko-KR" altLang="en-US" sz="800" b="1" dirty="0">
-              <a:solidFill>
-                <a:schemeClr val="tx1"/>
-              </a:solidFill>
-            </a:endParaRPr>
-          </a:p>
-        </p:txBody>
-      </p:sp>
-      <p:cxnSp>
-        <p:nvCxnSpPr>
-          <p:cNvPr id="50" name="직선 화살표 연결선 49">
-            <a:extLst>
-              <a:ext uri="{FF2B5EF4-FFF2-40B4-BE49-F238E27FC236}">
-                <a16:creationId xmlns:a16="http://schemas.microsoft.com/office/drawing/2014/main" id="{F4332BF3-6FFA-6068-9FD3-8838901A9E6F}"/>
-              </a:ext>
-            </a:extLst>
-          </p:cNvPr>
-          <p:cNvCxnSpPr>
-            <a:cxnSpLocks/>
-          </p:cNvCxnSpPr>
-          <p:nvPr/>
-        </p:nvCxnSpPr>
-        <p:spPr>
-          <a:xfrm flipH="1">
-            <a:off x="6812280" y="3242450"/>
-            <a:ext cx="5179" cy="314820"/>
-          </a:xfrm>
-          <a:prstGeom prst="straightConnector1">
-            <a:avLst/>
-          </a:prstGeom>
-          <a:ln>
-            <a:tailEnd type="triangle"/>
-          </a:ln>
-        </p:spPr>
-        <p:style>
-          <a:lnRef idx="2">
-            <a:schemeClr val="dk1"/>
-          </a:lnRef>
-          <a:fillRef idx="0">
-            <a:schemeClr val="dk1"/>
-          </a:fillRef>
-          <a:effectRef idx="1">
-            <a:schemeClr val="dk1"/>
-          </a:effectRef>
-          <a:fontRef idx="minor">
-            <a:schemeClr val="tx1"/>
-          </a:fontRef>
-        </p:style>
-      </p:cxnSp>
-      <p:sp>
-        <p:nvSpPr>
-          <p:cNvPr id="51" name="사각형: 둥근 모서리 50">
-            <a:extLst>
-              <a:ext uri="{FF2B5EF4-FFF2-40B4-BE49-F238E27FC236}">
-                <a16:creationId xmlns:a16="http://schemas.microsoft.com/office/drawing/2014/main" id="{1947358C-9DEE-5439-A29F-38DE92733393}"/>
-              </a:ext>
-            </a:extLst>
-          </p:cNvPr>
-          <p:cNvSpPr/>
-          <p:nvPr/>
-        </p:nvSpPr>
-        <p:spPr>
-          <a:xfrm>
-            <a:off x="6088380" y="3606800"/>
-            <a:ext cx="1476375" cy="466725"/>
-          </a:xfrm>
-          <a:prstGeom prst="roundRect">
-            <a:avLst/>
-          </a:prstGeom>
-          <a:solidFill>
-            <a:schemeClr val="tx2">
-              <a:lumMod val="10000"/>
-              <a:lumOff val="90000"/>
-            </a:schemeClr>
-          </a:solidFill>
-          <a:ln>
-            <a:solidFill>
-              <a:schemeClr val="tx2">
-                <a:lumMod val="25000"/>
-                <a:lumOff val="75000"/>
-              </a:schemeClr>
-            </a:solidFill>
-          </a:ln>
-        </p:spPr>
-        <p:style>
-          <a:lnRef idx="2">
-            <a:schemeClr val="accent1">
-              <a:shade val="15000"/>
-            </a:schemeClr>
-          </a:lnRef>
-          <a:fillRef idx="1">
-            <a:schemeClr val="accent1"/>
-          </a:fillRef>
-          <a:effectRef idx="0">
-            <a:schemeClr val="accent1"/>
-          </a:effectRef>
-          <a:fontRef idx="minor">
-            <a:schemeClr val="lt1"/>
-          </a:fontRef>
-        </p:style>
-        <p:txBody>
-          <a:bodyPr rtlCol="0" anchor="ctr"/>
-          <a:lstStyle/>
-          <a:p>
-            <a:pPr algn="ctr"/>
-            <a:r>
-              <a:rPr lang="en-US" altLang="ko-KR" sz="800" b="1" dirty="0">
-                <a:solidFill>
-                  <a:schemeClr val="tx1"/>
-                </a:solidFill>
-              </a:rPr>
-              <a:t>Final Safety Prediction</a:t>
-            </a:r>
-            <a:endParaRPr lang="ko-KR" altLang="en-US" sz="800" b="1" dirty="0">
-              <a:solidFill>
-                <a:schemeClr val="tx1"/>
-              </a:solidFill>
-            </a:endParaRPr>
-          </a:p>
-        </p:txBody>
-      </p:sp>
-      <p:cxnSp>
-        <p:nvCxnSpPr>
-          <p:cNvPr id="52" name="직선 화살표 연결선 51">
-            <a:extLst>
-              <a:ext uri="{FF2B5EF4-FFF2-40B4-BE49-F238E27FC236}">
-                <a16:creationId xmlns:a16="http://schemas.microsoft.com/office/drawing/2014/main" id="{BD823A5C-B228-EE28-B413-2D4B715A1647}"/>
-              </a:ext>
-            </a:extLst>
-          </p:cNvPr>
-          <p:cNvCxnSpPr>
-            <a:cxnSpLocks/>
-          </p:cNvCxnSpPr>
-          <p:nvPr/>
-        </p:nvCxnSpPr>
-        <p:spPr>
-          <a:xfrm flipH="1">
-            <a:off x="5958840" y="2423300"/>
-            <a:ext cx="5179" cy="314820"/>
-          </a:xfrm>
-          <a:prstGeom prst="straightConnector1">
-            <a:avLst/>
-          </a:prstGeom>
-          <a:ln>
-            <a:tailEnd type="triangle"/>
-          </a:ln>
-        </p:spPr>
-        <p:style>
-          <a:lnRef idx="2">
-            <a:schemeClr val="dk1"/>
-          </a:lnRef>
-          <a:fillRef idx="0">
-            <a:schemeClr val="dk1"/>
-          </a:fillRef>
-          <a:effectRef idx="1">
-            <a:schemeClr val="dk1"/>
-          </a:effectRef>
-          <a:fontRef idx="minor">
-            <a:schemeClr val="tx1"/>
-          </a:fontRef>
-        </p:style>
-      </p:cxnSp>
-      <p:cxnSp>
-        <p:nvCxnSpPr>
-          <p:cNvPr id="53" name="직선 화살표 연결선 52">
-            <a:extLst>
-              <a:ext uri="{FF2B5EF4-FFF2-40B4-BE49-F238E27FC236}">
-                <a16:creationId xmlns:a16="http://schemas.microsoft.com/office/drawing/2014/main" id="{E473324A-4276-1C65-A2A4-AE2FF765D5D6}"/>
-              </a:ext>
-            </a:extLst>
-          </p:cNvPr>
-          <p:cNvCxnSpPr>
-            <a:cxnSpLocks/>
-          </p:cNvCxnSpPr>
-          <p:nvPr/>
-        </p:nvCxnSpPr>
-        <p:spPr>
-          <a:xfrm flipH="1">
-            <a:off x="7741920" y="2423300"/>
-            <a:ext cx="5179" cy="314820"/>
-          </a:xfrm>
-          <a:prstGeom prst="straightConnector1">
-            <a:avLst/>
-          </a:prstGeom>
-          <a:ln>
-            <a:tailEnd type="triangle"/>
-          </a:ln>
-        </p:spPr>
-        <p:style>
-          <a:lnRef idx="2">
-            <a:schemeClr val="dk1"/>
-          </a:lnRef>
-          <a:fillRef idx="0">
-            <a:schemeClr val="dk1"/>
-          </a:fillRef>
-          <a:effectRef idx="1">
-            <a:schemeClr val="dk1"/>
-          </a:effectRef>
-          <a:fontRef idx="minor">
-            <a:schemeClr val="tx1"/>
-          </a:fontRef>
-        </p:style>
-      </p:cxnSp>
-      <p:sp>
-        <p:nvSpPr>
-          <p:cNvPr id="54" name="TextBox 53">
-            <a:extLst>
-              <a:ext uri="{FF2B5EF4-FFF2-40B4-BE49-F238E27FC236}">
-                <a16:creationId xmlns:a16="http://schemas.microsoft.com/office/drawing/2014/main" id="{54AA53E3-D015-279E-3B64-AD8C04B3B1D0}"/>
-              </a:ext>
-            </a:extLst>
-          </p:cNvPr>
-          <p:cNvSpPr txBox="1"/>
-          <p:nvPr/>
-        </p:nvSpPr>
-        <p:spPr>
-          <a:xfrm>
-            <a:off x="918211" y="1544321"/>
-            <a:ext cx="936475" cy="461665"/>
-          </a:xfrm>
-          <a:prstGeom prst="rect">
-            <a:avLst/>
-          </a:prstGeom>
-          <a:noFill/>
-        </p:spPr>
-        <p:txBody>
-          <a:bodyPr wrap="none" rtlCol="0">
-            <a:spAutoFit/>
-          </a:bodyPr>
-          <a:lstStyle/>
-          <a:p>
-            <a:r>
-              <a:rPr lang="en-US" altLang="ko-KR" sz="1200" b="1" dirty="0"/>
-              <a:t>Video Clip</a:t>
-            </a:r>
-          </a:p>
-          <a:p>
-            <a:pPr algn="ctr"/>
-            <a:r>
-              <a:rPr lang="en-US" altLang="ko-KR" sz="1200" b="1" dirty="0"/>
-              <a:t>(8 frames)</a:t>
-            </a:r>
-            <a:endParaRPr lang="ko-KR" altLang="en-US" sz="1200" b="1" dirty="0"/>
-          </a:p>
-        </p:txBody>
-      </p:sp>
     </p:spTree>
     <p:extLst>
       <p:ext uri="{BB962C8B-B14F-4D97-AF65-F5344CB8AC3E}">

</xml_diff>